<commit_message>
studies(payload-stability): name the two pitches in the tilt-in-waves deck
Xabier read "near resonance (2.65 s)" as a pitch resonance, which he
remembered higher. Two different motions were both called pitch:
- the hub / deck tilting as a whole (the buoys heaving against each other),
  resonating with heave at 2.6-2.9 s: where a shifted payload turns heave
  into pitch;
- each buoy's own pitch on its gimbal: the flume record's 2.76-2.9 s
  "pitch / tilt resonance" (pitch_check.py), which the weight preload moves
  to ~4.2 s with a payload.
Slides 2, 7 and 9 now say which is which; the band is computed from the
preloaded heave / pitch periods of the loaded cases.

Co-Authored-By: Claude Opus 5.5 <noreply@anthropic.com>
</commit_message>
<xml_diff>
--- a/studies/Payload_tilt_in_waves.pptx
+++ b/studies/Payload_tilt_in_waves.pptx
@@ -5645,7 +5645,7 @@
           <a:lstStyle/>
           <a:p>
             <a:r>
-              <a:t>At 2.65 s the cluster hub pitches 2.2 → 2.9 → 3.8° and the platform deck 1.8 → 2.5 → 3.1° (level → 5° → 10°). Away from resonance the tilt changes almost nothing.</a:t>
+              <a:t>At 2.65 s the cluster hub pitches 2.2 → 2.9 → 3.8° and the platform deck 1.8 → 2.5 → 3.1° (level → 5° → 10°): the shifted mass couples the article's heave and pitch, which resonate together at 2.6–2.9 s. Away from it, including at the buoys' rocking resonance (4.2 s), the tilt adds almost no pitch.</a:t>
             </a:r>
           </a:p>
         </p:txBody>
@@ -5785,7 +5785,7 @@
           <a:lstStyle/>
           <a:p>
             <a:r>
-              <a:t>With the preload, a payload puts the buoys' rocking resonance at ~4.2 s, where they rock 11–12.6° — level or tilted. Without the preload FloatSim gave ≤ 0.7° there and a false peak at 2.65 s.</a:t>
+              <a:t>With the preload, a payload puts the buoys' rocking resonance at ~4.2 s, where they rock 11–12.6° — level or tilted. Without the preload FloatSim gave ≤ 0.7° there and a peak at 2.65 s — the flume record's 2.76–2.9 s pitch resonance, which leaves out the load on the pins.</a:t>
             </a:r>
           </a:p>
         </p:txBody>
@@ -11615,7 +11615,7 @@
                 </a:solidFill>
                 <a:latin typeface="Calibri"/>
               </a:rPr>
-              <a:t>Pitch: </a:t>
+              <a:t>Hub / deck tilting: </a:t>
             </a:r>
             <a:r>
               <a:rPr sz="1600" b="0" i="0">
@@ -11624,7 +11624,7 @@
                 </a:solidFill>
                 <a:latin typeface="Calibri"/>
               </a:rPr>
-              <a:t>near resonance (2.65 s) the tilt turns heave into pitch — 2.2 → 3.8° on the cluster hub, 1.8 → 3.1° on the platform deck, level → 10°.</a:t>
+              <a:t>near the article's heave and tilt resonance (2.6–2.9 s; the 2.65 s wave) the tilt turns heave into pitch: 2.2 → 3.8° on the cluster hub, 1.8 → 3.1° on the platform deck, level → 10°.</a:t>
             </a:r>
           </a:p>
           <a:p>
@@ -11665,7 +11665,7 @@
                 </a:solidFill>
                 <a:latin typeface="Calibri"/>
               </a:rPr>
-              <a:t>Rocking: </a:t>
+              <a:t>Buoys' own pitch: </a:t>
             </a:r>
             <a:r>
               <a:rPr sz="1600" b="0" i="0">
@@ -11674,7 +11674,7 @@
                 </a:solidFill>
                 <a:latin typeface="Calibri"/>
               </a:rPr>
-              <a:t>all the buoys rock together at one period, ~4.2 s, whatever the tilt — keep a loaded article out of waves near 4.2 s.</a:t>
+              <a:t>each buoy rocking on its gimbal — the flume record's 2.76–2.9 s pitch resonance — moves to ~4.2 s with a payload, whatever the tilt: keep a loaded article out of waves near 4.2 s.</a:t>
             </a:r>
           </a:p>
         </p:txBody>
@@ -14386,7 +14386,7 @@
                 </a:solidFill>
                 <a:latin typeface="Calibri"/>
               </a:rPr>
-              <a:t>Near resonance, the tilt turns heave into pitch</a:t>
+              <a:t>Near the heave resonance, the tilt turns heave into pitch</a:t>
             </a:r>
           </a:p>
         </p:txBody>
@@ -14425,7 +14425,7 @@
                 </a:solidFill>
                 <a:latin typeface="Calibri"/>
               </a:rPr>
-              <a:t>Pitch of the hub / deck against wave period</a:t>
+              <a:t>Hub / deck pitch (the whole article tilting; not the buoys' own pitch) — resonates with heave at 2.6–2.9 s</a:t>
             </a:r>
           </a:p>
         </p:txBody>
@@ -14500,7 +14500,7 @@
                 </a:solidFill>
                 <a:latin typeface="Calibri"/>
               </a:rPr>
-              <a:t>At 2.65 s the cluster hub pitches 2.2 → 2.9 → 3.8° and the platform deck 1.8 → 2.5 → 3.1° (level → 5° → 10°). Away from resonance the tilt changes almost nothing.</a:t>
+              <a:t>At 2.65 s the cluster hub pitches 2.2 → 2.9 → 3.8° and the platform deck 1.8 → 2.5 → 3.1° (level → 5° → 10°): the shifted mass couples the article's heave and pitch, which resonate together at 2.6–2.9 s. Away from it, including at the buoys' rocking resonance (4.2 s), the tilt adds almost no pitch.</a:t>
             </a:r>
           </a:p>
         </p:txBody>
@@ -14783,7 +14783,7 @@
                 </a:solidFill>
                 <a:latin typeface="Calibri"/>
               </a:rPr>
-              <a:t>Buoy rocking on its gimbal (dashed: FloatSim without the weight preload, payload centred)</a:t>
+              <a:t>The buoys' own pitch on their gimbals (dashed: FloatSim without the weight preload, payload centred)</a:t>
             </a:r>
           </a:p>
         </p:txBody>
@@ -14858,7 +14858,7 @@
                 </a:solidFill>
                 <a:latin typeface="Calibri"/>
               </a:rPr>
-              <a:t>With the preload, a payload puts the buoys' rocking resonance at ~4.2 s, where they rock 11–12.6° — level or tilted. Without the preload FloatSim gave ≤ 0.7° there and a false peak at 2.65 s.</a:t>
+              <a:t>With the preload, a payload puts the buoys' rocking resonance at ~4.2 s, where they rock 11–12.6° — level or tilted. Without the preload FloatSim gave ≤ 0.7° there and a peak at 2.65 s — the flume record's 2.76–2.9 s pitch resonance, which leaves out the load on the pins.</a:t>
             </a:r>
           </a:p>
         </p:txBody>

</xml_diff>